<commit_message>
presentations: +2 formula slides — gtpo_conf vs gtpo_ema_flipped, length-penalty hack
Slide 8: method difference (token confidence C; conf=raw monotone weighting vs
ema_flipped=EMA-smoothed + swapped O+/O- roles), formulas only.
Slide 9: length-penalty hack for gtpo_ema_flipped's length explosion (O+ bonus
~1/EMA(C) farms length) — soft seq-reward penalty + length-normalized bonus.
</commit_message>
<xml_diff>
--- a/presentations/weekly_update_2026_06_18/weekly_update_2026_06_18.pptx
+++ b/presentations/weekly_update_2026_06_18/weekly_update_2026_06_18.pptx
@@ -13,6 +13,8 @@
     <p:sldId id="261" r:id="rId12"/>
     <p:sldId id="262" r:id="rId13"/>
     <p:sldId id="263" r:id="rId14"/>
+    <p:sldId id="264" r:id="rId15"/>
+    <p:sldId id="265" r:id="rId16"/>
   </p:sldIdLst>
   <p:sldSz cx="12191695" cy="6858000" type="screen4x3"/>
   <p:notesSz cx="6858000" cy="9144000"/>
@@ -3260,6 +3262,290 @@
 </p:sld>
 </file>
 
+<file path=ppt/slides/slide10.xml><?xml version="1.0" encoding="utf-8"?>
+<p:sld xmlns:a="http://schemas.openxmlformats.org/drawingml/2006/main" xmlns:p="http://schemas.openxmlformats.org/presentationml/2006/main" xmlns:r="http://schemas.openxmlformats.org/officeDocument/2006/relationships">
+  <p:cSld>
+    <p:bg>
+      <p:bgPr>
+        <a:solidFill>
+          <a:srgbClr val="FFFFFF"/>
+        </a:solidFill>
+        <a:effectLst/>
+      </p:bgPr>
+    </p:bg>
+    <p:spTree>
+      <p:nvGrpSpPr>
+        <p:cNvPr id="1" name=""/>
+        <p:cNvGrpSpPr/>
+        <p:nvPr/>
+      </p:nvGrpSpPr>
+      <p:grpSpPr/>
+      <p:sp>
+        <p:nvSpPr>
+          <p:cNvPr id="2" name="TextBox 1"/>
+          <p:cNvSpPr txBox="1"/>
+          <p:nvPr/>
+        </p:nvSpPr>
+        <p:spPr>
+          <a:xfrm>
+            <a:off x="548640" y="411480"/>
+            <a:ext cx="11064240" cy="731520"/>
+          </a:xfrm>
+          <a:prstGeom prst="rect">
+            <a:avLst/>
+          </a:prstGeom>
+          <a:noFill/>
+        </p:spPr>
+        <p:txBody>
+          <a:bodyPr wrap="square">
+            <a:spAutoFit/>
+          </a:bodyPr>
+          <a:lstStyle/>
+          <a:p>
+            <a:pPr algn="l"/>
+            <a:r>
+              <a:rPr sz="2800" b="1">
+                <a:solidFill>
+                  <a:srgbClr val="1F2937"/>
+                </a:solidFill>
+                <a:latin typeface="Calibri"/>
+              </a:rPr>
+              <a:t>Length-penalty hack (gtpo_ema_flipped)</a:t>
+            </a:r>
+          </a:p>
+        </p:txBody>
+      </p:sp>
+      <p:sp>
+        <p:nvSpPr>
+          <p:cNvPr id="3" name="Rectangle 2"/>
+          <p:cNvSpPr/>
+          <p:nvPr/>
+        </p:nvSpPr>
+        <p:spPr>
+          <a:xfrm>
+            <a:off x="566928" y="1234440"/>
+            <a:ext cx="2377440" cy="38100"/>
+          </a:xfrm>
+          <a:prstGeom prst="rect">
+            <a:avLst/>
+          </a:prstGeom>
+          <a:solidFill>
+            <a:srgbClr val="4F46E5"/>
+          </a:solidFill>
+          <a:ln>
+            <a:noFill/>
+          </a:ln>
+          <a:effectLst/>
+        </p:spPr>
+        <p:style>
+          <a:lnRef idx="1">
+            <a:schemeClr val="accent1"/>
+          </a:lnRef>
+          <a:fillRef idx="3">
+            <a:schemeClr val="accent1"/>
+          </a:fillRef>
+          <a:effectRef idx="2">
+            <a:schemeClr val="accent1"/>
+          </a:effectRef>
+          <a:fontRef idx="minor">
+            <a:schemeClr val="lt1"/>
+          </a:fontRef>
+        </p:style>
+        <p:txBody>
+          <a:bodyPr rtlCol="0" anchor="ctr"/>
+          <a:lstStyle/>
+          <a:p>
+            <a:pPr algn="ctr"/>
+          </a:p>
+        </p:txBody>
+      </p:sp>
+      <p:sp>
+        <p:nvSpPr>
+          <p:cNvPr id="4" name="TextBox 3"/>
+          <p:cNvSpPr txBox="1"/>
+          <p:nvPr/>
+        </p:nvSpPr>
+        <p:spPr>
+          <a:xfrm>
+            <a:off x="731520" y="1600200"/>
+            <a:ext cx="10789920" cy="4937760"/>
+          </a:xfrm>
+          <a:prstGeom prst="rect">
+            <a:avLst/>
+          </a:prstGeom>
+          <a:noFill/>
+        </p:spPr>
+        <p:txBody>
+          <a:bodyPr wrap="square">
+            <a:spAutoFit/>
+          </a:bodyPr>
+          <a:lstStyle/>
+          <a:p>
+            <a:pPr>
+              <a:spcBef>
+                <a:spcPts val="0"/>
+              </a:spcBef>
+              <a:spcAft>
+                <a:spcPts val="300"/>
+              </a:spcAft>
+            </a:pPr>
+            <a:r>
+              <a:rPr sz="1500" b="1">
+                <a:solidFill>
+                  <a:srgbClr val="4F46E5"/>
+                </a:solidFill>
+                <a:latin typeface="Calibri"/>
+              </a:rPr>
+              <a:t>why it explodes (exp_058)</a:t>
+            </a:r>
+          </a:p>
+          <a:p>
+            <a:pPr>
+              <a:spcAft>
+                <a:spcPts val="300"/>
+              </a:spcAft>
+            </a:pPr>
+            <a:r>
+              <a:rPr sz="1600">
+                <a:solidFill>
+                  <a:srgbClr val="1F2937"/>
+                </a:solidFill>
+                <a:latin typeface="Consolas"/>
+              </a:rPr>
+              <a:t>O⁺ bonus ∝ 1/EMA(C) → rewards low-confidence tokens</a:t>
+            </a:r>
+          </a:p>
+          <a:p>
+            <a:pPr>
+              <a:spcAft>
+                <a:spcPts val="300"/>
+              </a:spcAft>
+            </a:pPr>
+            <a:r>
+              <a:rPr sz="1600">
+                <a:solidFill>
+                  <a:srgbClr val="1F2937"/>
+                </a:solidFill>
+                <a:latin typeface="Consolas"/>
+              </a:rPr>
+              <a:t>→ model farms length:  640 → 3400 tok,  boxed → 0</a:t>
+            </a:r>
+          </a:p>
+          <a:p>
+            <a:pPr>
+              <a:spcBef>
+                <a:spcPts val="1200"/>
+              </a:spcBef>
+              <a:spcAft>
+                <a:spcPts val="300"/>
+              </a:spcAft>
+            </a:pPr>
+            <a:r>
+              <a:rPr sz="1500" b="1">
+                <a:solidFill>
+                  <a:srgbClr val="4F46E5"/>
+                </a:solidFill>
+                <a:latin typeface="Calibri"/>
+              </a:rPr>
+              <a:t>fix 1 — soft length penalty on seq reward (before O⁺/O⁻ split)</a:t>
+            </a:r>
+          </a:p>
+          <a:p>
+            <a:pPr>
+              <a:spcAft>
+                <a:spcPts val="300"/>
+              </a:spcAft>
+            </a:pPr>
+            <a:r>
+              <a:rPr sz="1600">
+                <a:solidFill>
+                  <a:srgbClr val="1F2937"/>
+                </a:solidFill>
+                <a:latin typeface="Consolas"/>
+              </a:rPr>
+              <a:t>rᵢ ← rᵢ − γ · max(0, |oᵢ| − L₀) / L₀        (γ≈0.5, L₀ = target len)</a:t>
+            </a:r>
+          </a:p>
+          <a:p>
+            <a:pPr>
+              <a:spcBef>
+                <a:spcPts val="1200"/>
+              </a:spcBef>
+              <a:spcAft>
+                <a:spcPts val="300"/>
+              </a:spcAft>
+            </a:pPr>
+            <a:r>
+              <a:rPr sz="1500" b="1">
+                <a:solidFill>
+                  <a:srgbClr val="4F46E5"/>
+                </a:solidFill>
+                <a:latin typeface="Calibri"/>
+              </a:rPr>
+              <a:t>fix 2 — length-normalize the bonus (can't grow with length)</a:t>
+            </a:r>
+          </a:p>
+          <a:p>
+            <a:pPr>
+              <a:spcAft>
+                <a:spcPts val="300"/>
+              </a:spcAft>
+            </a:pPr>
+            <a:r>
+              <a:rPr sz="1600">
+                <a:solidFill>
+                  <a:srgbClr val="1F2937"/>
+                </a:solidFill>
+                <a:latin typeface="Consolas"/>
+              </a:rPr>
+              <a:t>bonusₜ ← bonusₜ · L₀ / max(L₀, |oᵢ|)</a:t>
+            </a:r>
+          </a:p>
+          <a:p>
+            <a:pPr>
+              <a:spcBef>
+                <a:spcPts val="1200"/>
+              </a:spcBef>
+              <a:spcAft>
+                <a:spcPts val="300"/>
+              </a:spcAft>
+            </a:pPr>
+            <a:r>
+              <a:rPr sz="1500" b="1">
+                <a:solidFill>
+                  <a:srgbClr val="4F46E5"/>
+                </a:solidFill>
+                <a:latin typeface="Calibri"/>
+              </a:rPr>
+              <a:t>effect</a:t>
+            </a:r>
+          </a:p>
+          <a:p>
+            <a:pPr>
+              <a:spcAft>
+                <a:spcPts val="300"/>
+              </a:spcAft>
+            </a:pPr>
+            <a:r>
+              <a:rPr sz="1600">
+                <a:solidFill>
+                  <a:srgbClr val="1F2937"/>
+                </a:solidFill>
+                <a:latin typeface="Consolas"/>
+              </a:rPr>
+              <a:t>caps exploration-reward per completion → removes the incentive to ramble</a:t>
+            </a:r>
+          </a:p>
+        </p:txBody>
+      </p:sp>
+    </p:spTree>
+  </p:cSld>
+  <p:clrMapOvr>
+    <a:masterClrMapping/>
+  </p:clrMapOvr>
+</p:sld>
+</file>
+
 <file path=ppt/slides/slide2.xml><?xml version="1.0" encoding="utf-8"?>
 <p:sld xmlns:a="http://schemas.openxmlformats.org/drawingml/2006/main" xmlns:p="http://schemas.openxmlformats.org/presentationml/2006/main" xmlns:r="http://schemas.openxmlformats.org/officeDocument/2006/relationships">
   <p:cSld>
@@ -4645,6 +4931,335 @@
                 <a:latin typeface="Calibri"/>
               </a:rPr>
               <a:t>•  Control (exp_060) proves the code is correct — the historical "shaping helps" results were almost certainly measured with the shaping bypassed.</a:t>
+            </a:r>
+          </a:p>
+        </p:txBody>
+      </p:sp>
+    </p:spTree>
+  </p:cSld>
+  <p:clrMapOvr>
+    <a:masterClrMapping/>
+  </p:clrMapOvr>
+</p:sld>
+</file>
+
+<file path=ppt/slides/slide9.xml><?xml version="1.0" encoding="utf-8"?>
+<p:sld xmlns:a="http://schemas.openxmlformats.org/drawingml/2006/main" xmlns:p="http://schemas.openxmlformats.org/presentationml/2006/main" xmlns:r="http://schemas.openxmlformats.org/officeDocument/2006/relationships">
+  <p:cSld>
+    <p:bg>
+      <p:bgPr>
+        <a:solidFill>
+          <a:srgbClr val="FFFFFF"/>
+        </a:solidFill>
+        <a:effectLst/>
+      </p:bgPr>
+    </p:bg>
+    <p:spTree>
+      <p:nvGrpSpPr>
+        <p:cNvPr id="1" name=""/>
+        <p:cNvGrpSpPr/>
+        <p:nvPr/>
+      </p:nvGrpSpPr>
+      <p:grpSpPr/>
+      <p:sp>
+        <p:nvSpPr>
+          <p:cNvPr id="2" name="TextBox 1"/>
+          <p:cNvSpPr txBox="1"/>
+          <p:nvPr/>
+        </p:nvSpPr>
+        <p:spPr>
+          <a:xfrm>
+            <a:off x="548640" y="411480"/>
+            <a:ext cx="11064240" cy="731520"/>
+          </a:xfrm>
+          <a:prstGeom prst="rect">
+            <a:avLst/>
+          </a:prstGeom>
+          <a:noFill/>
+        </p:spPr>
+        <p:txBody>
+          <a:bodyPr wrap="square">
+            <a:spAutoFit/>
+          </a:bodyPr>
+          <a:lstStyle/>
+          <a:p>
+            <a:pPr algn="l"/>
+            <a:r>
+              <a:rPr sz="2800" b="1">
+                <a:solidFill>
+                  <a:srgbClr val="1F2937"/>
+                </a:solidFill>
+                <a:latin typeface="Calibri"/>
+              </a:rPr>
+              <a:t>gtpo_conf  vs  gtpo_ema_flipped</a:t>
+            </a:r>
+          </a:p>
+        </p:txBody>
+      </p:sp>
+      <p:sp>
+        <p:nvSpPr>
+          <p:cNvPr id="3" name="Rectangle 2"/>
+          <p:cNvSpPr/>
+          <p:nvPr/>
+        </p:nvSpPr>
+        <p:spPr>
+          <a:xfrm>
+            <a:off x="566928" y="1234440"/>
+            <a:ext cx="2377440" cy="38100"/>
+          </a:xfrm>
+          <a:prstGeom prst="rect">
+            <a:avLst/>
+          </a:prstGeom>
+          <a:solidFill>
+            <a:srgbClr val="4F46E5"/>
+          </a:solidFill>
+          <a:ln>
+            <a:noFill/>
+          </a:ln>
+          <a:effectLst/>
+        </p:spPr>
+        <p:style>
+          <a:lnRef idx="1">
+            <a:schemeClr val="accent1"/>
+          </a:lnRef>
+          <a:fillRef idx="3">
+            <a:schemeClr val="accent1"/>
+          </a:fillRef>
+          <a:effectRef idx="2">
+            <a:schemeClr val="accent1"/>
+          </a:effectRef>
+          <a:fontRef idx="minor">
+            <a:schemeClr val="lt1"/>
+          </a:fontRef>
+        </p:style>
+        <p:txBody>
+          <a:bodyPr rtlCol="0" anchor="ctr"/>
+          <a:lstStyle/>
+          <a:p>
+            <a:pPr algn="ctr"/>
+          </a:p>
+        </p:txBody>
+      </p:sp>
+      <p:sp>
+        <p:nvSpPr>
+          <p:cNvPr id="4" name="TextBox 3"/>
+          <p:cNvSpPr txBox="1"/>
+          <p:nvPr/>
+        </p:nvSpPr>
+        <p:spPr>
+          <a:xfrm>
+            <a:off x="731520" y="1600200"/>
+            <a:ext cx="10789920" cy="4937760"/>
+          </a:xfrm>
+          <a:prstGeom prst="rect">
+            <a:avLst/>
+          </a:prstGeom>
+          <a:noFill/>
+        </p:spPr>
+        <p:txBody>
+          <a:bodyPr wrap="square">
+            <a:spAutoFit/>
+          </a:bodyPr>
+          <a:lstStyle/>
+          <a:p>
+            <a:pPr>
+              <a:spcAft>
+                <a:spcPts val="300"/>
+              </a:spcAft>
+            </a:pPr>
+            <a:r>
+              <a:rPr sz="1600">
+                <a:solidFill>
+                  <a:srgbClr val="1F2937"/>
+                </a:solidFill>
+                <a:latin typeface="Consolas"/>
+              </a:rPr>
+              <a:t>both:   Cₜ = −mean₍top-k₎ log π(v | ·)        # token confidence</a:t>
+            </a:r>
+          </a:p>
+          <a:p>
+            <a:pPr>
+              <a:spcAft>
+                <a:spcPts val="300"/>
+              </a:spcAft>
+            </a:pPr>
+            <a:r>
+              <a:rPr sz="1600">
+                <a:solidFill>
+                  <a:srgbClr val="1F2937"/>
+                </a:solidFill>
+                <a:latin typeface="Consolas"/>
+              </a:rPr>
+              <a:t>both:   separate z-norm over O⁺ / O⁻ tokens</a:t>
+            </a:r>
+          </a:p>
+          <a:p>
+            <a:pPr>
+              <a:spcBef>
+                <a:spcPts val="1200"/>
+              </a:spcBef>
+              <a:spcAft>
+                <a:spcPts val="300"/>
+              </a:spcAft>
+            </a:pPr>
+            <a:r>
+              <a:rPr sz="1500" b="1">
+                <a:solidFill>
+                  <a:srgbClr val="4F46E5"/>
+                </a:solidFill>
+                <a:latin typeface="Calibri"/>
+              </a:rPr>
+              <a:t>gtpo_conf  — raw, monotone</a:t>
+            </a:r>
+          </a:p>
+          <a:p>
+            <a:pPr>
+              <a:spcAft>
+                <a:spcPts val="300"/>
+              </a:spcAft>
+            </a:pPr>
+            <a:r>
+              <a:rPr sz="1600">
+                <a:solidFill>
+                  <a:srgbClr val="1F2937"/>
+                </a:solidFill>
+                <a:latin typeface="Consolas"/>
+              </a:rPr>
+              <a:t>O⁺:  r̃ₜ = α₁ + α₂·(C̃ₜ / Σ C̃)·dₜ ,   C̃ = log(1+C)</a:t>
+            </a:r>
+          </a:p>
+          <a:p>
+            <a:pPr>
+              <a:spcAft>
+                <a:spcPts val="300"/>
+              </a:spcAft>
+            </a:pPr>
+            <a:r>
+              <a:rPr sz="1600">
+                <a:solidFill>
+                  <a:srgbClr val="1F2937"/>
+                </a:solidFill>
+                <a:latin typeface="Consolas"/>
+              </a:rPr>
+              <a:t>O⁻:  r̃ₜ = −[α₁ + α₂·(Ĩₜ / Σ Ĩ)·hₜ] ,  Ĩ = log(1+1/C)</a:t>
+            </a:r>
+          </a:p>
+          <a:p>
+            <a:pPr>
+              <a:spcBef>
+                <a:spcPts val="1200"/>
+              </a:spcBef>
+              <a:spcAft>
+                <a:spcPts val="300"/>
+              </a:spcAft>
+            </a:pPr>
+            <a:r>
+              <a:rPr sz="1500" b="1">
+                <a:solidFill>
+                  <a:srgbClr val="4F46E5"/>
+                </a:solidFill>
+                <a:latin typeface="Calibri"/>
+              </a:rPr>
+              <a:t>gtpo_ema_flipped  — EMA-smoothed + roles swapped</a:t>
+            </a:r>
+          </a:p>
+          <a:p>
+            <a:pPr>
+              <a:spcAft>
+                <a:spcPts val="300"/>
+              </a:spcAft>
+            </a:pPr>
+            <a:r>
+              <a:rPr sz="1600">
+                <a:solidFill>
+                  <a:srgbClr val="1F2937"/>
+                </a:solidFill>
+                <a:latin typeface="Consolas"/>
+              </a:rPr>
+              <a:t>EMAₜ = λ·EMAₜ₋₁ + (1−λ)·Cₜ</a:t>
+            </a:r>
+          </a:p>
+          <a:p>
+            <a:pPr>
+              <a:spcAft>
+                <a:spcPts val="300"/>
+              </a:spcAft>
+            </a:pPr>
+            <a:r>
+              <a:rPr sz="1600">
+                <a:solidFill>
+                  <a:srgbClr val="1F2937"/>
+                </a:solidFill>
+                <a:latin typeface="Consolas"/>
+              </a:rPr>
+              <a:t>O⁺ weight = 1/EMAₜ   (reward LOW-confidence tokens)</a:t>
+            </a:r>
+          </a:p>
+          <a:p>
+            <a:pPr>
+              <a:spcAft>
+                <a:spcPts val="300"/>
+              </a:spcAft>
+            </a:pPr>
+            <a:r>
+              <a:rPr sz="1600">
+                <a:solidFill>
+                  <a:srgbClr val="1F2937"/>
+                </a:solidFill>
+                <a:latin typeface="Consolas"/>
+              </a:rPr>
+              <a:t>O⁻ weight =  EMAₜ     (penalize HIGH-confidence tokens)</a:t>
+            </a:r>
+          </a:p>
+          <a:p>
+            <a:pPr>
+              <a:spcBef>
+                <a:spcPts val="1200"/>
+              </a:spcBef>
+              <a:spcAft>
+                <a:spcPts val="300"/>
+              </a:spcAft>
+            </a:pPr>
+            <a:r>
+              <a:rPr sz="1500" b="1">
+                <a:solidFill>
+                  <a:srgbClr val="4F46E5"/>
+                </a:solidFill>
+                <a:latin typeface="Calibri"/>
+              </a:rPr>
+              <a:t>difference</a:t>
+            </a:r>
+          </a:p>
+          <a:p>
+            <a:pPr>
+              <a:spcAft>
+                <a:spcPts val="300"/>
+              </a:spcAft>
+            </a:pPr>
+            <a:r>
+              <a:rPr sz="1600">
+                <a:solidFill>
+                  <a:srgbClr val="1F2937"/>
+                </a:solidFill>
+                <a:latin typeface="Consolas"/>
+              </a:rPr>
+              <a:t>conf = instantaneous C, high-C → high bonus</a:t>
+            </a:r>
+          </a:p>
+          <a:p>
+            <a:pPr>
+              <a:spcAft>
+                <a:spcPts val="300"/>
+              </a:spcAft>
+            </a:pPr>
+            <a:r>
+              <a:rPr sz="1600">
+                <a:solidFill>
+                  <a:srgbClr val="1F2937"/>
+                </a:solidFill>
+                <a:latin typeface="Consolas"/>
+              </a:rPr>
+              <a:t>ema  = smoothed C  +  inverted O⁺/O⁻ weighting</a:t>
             </a:r>
           </a:p>
         </p:txBody>

</xml_diff>